<commit_message>
segmentation and detection added
</commit_message>
<xml_diff>
--- a/ml_course_ru/semester_2/lecture_03_semantic_networks/semantic_networks.pptx
+++ b/ml_course_ru/semester_2/lecture_03_semantic_networks/semantic_networks.pptx
@@ -389,6 +389,704 @@
           <a:bodyPr/>
           <a:lstStyle/>
           <a:p>
+            <a:r>
+              <a:rPr lang="ru-RU" sz="1200" b="1" kern="1200" dirty="0">
+                <a:solidFill>
+                  <a:schemeClr val="tx1"/>
+                </a:solidFill>
+                <a:effectLst/>
+                <a:latin typeface="+mn-lt"/>
+                <a:ea typeface="+mn-ea"/>
+                <a:cs typeface="+mn-cs"/>
+              </a:rPr>
+              <a:t>Прагматические семантические сети (</a:t>
+            </a:r>
+            <a:r>
+              <a:rPr lang="ru-RU" sz="1200" b="1" kern="1200" dirty="0" err="1">
+                <a:solidFill>
+                  <a:schemeClr val="tx1"/>
+                </a:solidFill>
+                <a:effectLst/>
+                <a:latin typeface="+mn-lt"/>
+                <a:ea typeface="+mn-ea"/>
+                <a:cs typeface="+mn-cs"/>
+              </a:rPr>
+              <a:t>Pragmatic</a:t>
+            </a:r>
+            <a:r>
+              <a:rPr lang="ru-RU" sz="1200" b="1" kern="1200" dirty="0">
+                <a:solidFill>
+                  <a:schemeClr val="tx1"/>
+                </a:solidFill>
+                <a:effectLst/>
+                <a:latin typeface="+mn-lt"/>
+                <a:ea typeface="+mn-ea"/>
+                <a:cs typeface="+mn-cs"/>
+              </a:rPr>
+              <a:t> </a:t>
+            </a:r>
+            <a:r>
+              <a:rPr lang="ru-RU" sz="1200" b="1" kern="1200" dirty="0" err="1">
+                <a:solidFill>
+                  <a:schemeClr val="tx1"/>
+                </a:solidFill>
+                <a:effectLst/>
+                <a:latin typeface="+mn-lt"/>
+                <a:ea typeface="+mn-ea"/>
+                <a:cs typeface="+mn-cs"/>
+              </a:rPr>
+              <a:t>Semantic</a:t>
+            </a:r>
+            <a:r>
+              <a:rPr lang="ru-RU" sz="1200" b="1" kern="1200" dirty="0">
+                <a:solidFill>
+                  <a:schemeClr val="tx1"/>
+                </a:solidFill>
+                <a:effectLst/>
+                <a:latin typeface="+mn-lt"/>
+                <a:ea typeface="+mn-ea"/>
+                <a:cs typeface="+mn-cs"/>
+              </a:rPr>
+              <a:t> Networks)</a:t>
+            </a:r>
+          </a:p>
+          <a:p>
+            <a:r>
+              <a:rPr lang="ru-RU" sz="1200" kern="1200" dirty="0">
+                <a:solidFill>
+                  <a:schemeClr val="tx1"/>
+                </a:solidFill>
+                <a:effectLst/>
+                <a:latin typeface="+mn-lt"/>
+                <a:ea typeface="+mn-ea"/>
+                <a:cs typeface="+mn-cs"/>
+              </a:rPr>
+              <a:t>Прагматические сети представляют собой структуру, где связи между понятиями зависят от конкретного контекста или ситуации. В них отношения между понятиями зависят от задач и условий использования.</a:t>
+            </a:r>
+          </a:p>
+          <a:p>
+            <a:r>
+              <a:rPr lang="ru-RU" sz="1200" b="1" kern="1200" dirty="0">
+                <a:solidFill>
+                  <a:schemeClr val="tx1"/>
+                </a:solidFill>
+                <a:effectLst/>
+                <a:latin typeface="+mn-lt"/>
+                <a:ea typeface="+mn-ea"/>
+                <a:cs typeface="+mn-cs"/>
+              </a:rPr>
+              <a:t>Особенности:</a:t>
+            </a:r>
+            <a:endParaRPr lang="ru-RU" sz="1200" kern="1200" dirty="0">
+              <a:solidFill>
+                <a:schemeClr val="tx1"/>
+              </a:solidFill>
+              <a:effectLst/>
+              <a:latin typeface="+mn-lt"/>
+              <a:ea typeface="+mn-ea"/>
+              <a:cs typeface="+mn-cs"/>
+            </a:endParaRPr>
+          </a:p>
+          <a:p>
+            <a:pPr lvl="0"/>
+            <a:r>
+              <a:rPr lang="ru-RU" sz="1200" kern="1200" dirty="0">
+                <a:solidFill>
+                  <a:schemeClr val="tx1"/>
+                </a:solidFill>
+                <a:effectLst/>
+                <a:latin typeface="+mn-lt"/>
+                <a:ea typeface="+mn-ea"/>
+                <a:cs typeface="+mn-cs"/>
+              </a:rPr>
+              <a:t>Контекстуально зависимые связи между узлами.</a:t>
+            </a:r>
+          </a:p>
+          <a:p>
+            <a:pPr lvl="0"/>
+            <a:r>
+              <a:rPr lang="ru-RU" sz="1200" kern="1200" dirty="0">
+                <a:solidFill>
+                  <a:schemeClr val="tx1"/>
+                </a:solidFill>
+                <a:effectLst/>
+                <a:latin typeface="+mn-lt"/>
+                <a:ea typeface="+mn-ea"/>
+                <a:cs typeface="+mn-cs"/>
+              </a:rPr>
+              <a:t>Связи могут менять своё значение или силу в зависимости от ситуации.</a:t>
+            </a:r>
+          </a:p>
+          <a:p>
+            <a:pPr lvl="0"/>
+            <a:r>
+              <a:rPr lang="ru-RU" sz="1200" kern="1200" dirty="0">
+                <a:solidFill>
+                  <a:schemeClr val="tx1"/>
+                </a:solidFill>
+                <a:effectLst/>
+                <a:latin typeface="+mn-lt"/>
+                <a:ea typeface="+mn-ea"/>
+                <a:cs typeface="+mn-cs"/>
+              </a:rPr>
+              <a:t>Применяются в сложных когнитивных моделях и сценариях, где значение понятий зависит от контекста.</a:t>
+            </a:r>
+          </a:p>
+          <a:p>
+            <a:r>
+              <a:rPr lang="ru-RU" sz="1200" b="1" kern="1200" dirty="0">
+                <a:solidFill>
+                  <a:schemeClr val="tx1"/>
+                </a:solidFill>
+                <a:effectLst/>
+                <a:latin typeface="+mn-lt"/>
+                <a:ea typeface="+mn-ea"/>
+                <a:cs typeface="+mn-cs"/>
+              </a:rPr>
+              <a:t>Пример:</a:t>
+            </a:r>
+            <a:endParaRPr lang="ru-RU" sz="1200" kern="1200" dirty="0">
+              <a:solidFill>
+                <a:schemeClr val="tx1"/>
+              </a:solidFill>
+              <a:effectLst/>
+              <a:latin typeface="+mn-lt"/>
+              <a:ea typeface="+mn-ea"/>
+              <a:cs typeface="+mn-cs"/>
+            </a:endParaRPr>
+          </a:p>
+          <a:p>
+            <a:pPr lvl="0"/>
+            <a:r>
+              <a:rPr lang="ru-RU" sz="1200" kern="1200" dirty="0">
+                <a:solidFill>
+                  <a:schemeClr val="tx1"/>
+                </a:solidFill>
+                <a:effectLst/>
+                <a:latin typeface="+mn-lt"/>
+                <a:ea typeface="+mn-ea"/>
+                <a:cs typeface="+mn-cs"/>
+              </a:rPr>
+              <a:t>Узлы: "Врач", "Пациент", "Больница".</a:t>
+            </a:r>
+          </a:p>
+          <a:p>
+            <a:pPr lvl="0"/>
+            <a:r>
+              <a:rPr lang="ru-RU" sz="1200" kern="1200" dirty="0">
+                <a:solidFill>
+                  <a:schemeClr val="tx1"/>
+                </a:solidFill>
+                <a:effectLst/>
+                <a:latin typeface="+mn-lt"/>
+                <a:ea typeface="+mn-ea"/>
+                <a:cs typeface="+mn-cs"/>
+              </a:rPr>
+              <a:t>Связи: "Врач — лечит — Пациент", "Пациент — приходит в — Больница", "Больница — предоставляет услуги — Пациенту".</a:t>
+            </a:r>
+          </a:p>
+          <a:p>
+            <a:r>
+              <a:rPr lang="ru-RU" sz="1200" kern="1200" dirty="0">
+                <a:solidFill>
+                  <a:schemeClr val="tx1"/>
+                </a:solidFill>
+                <a:effectLst/>
+                <a:latin typeface="+mn-lt"/>
+                <a:ea typeface="+mn-ea"/>
+                <a:cs typeface="+mn-cs"/>
+              </a:rPr>
+              <a:t>Прагматические сети особенно полезны для моделирования знаний в системе, где одна и та же информация может быть интерпретирована по-разному в зависимости от ситуации (например, в здравоохранении или образовании).</a:t>
+            </a:r>
+          </a:p>
+          <a:p>
+            <a:r>
+              <a:rPr lang="ru-RU" sz="1200" b="1" kern="1200" dirty="0">
+                <a:solidFill>
+                  <a:schemeClr val="tx1"/>
+                </a:solidFill>
+                <a:effectLst/>
+                <a:latin typeface="+mn-lt"/>
+                <a:ea typeface="+mn-ea"/>
+                <a:cs typeface="+mn-cs"/>
+              </a:rPr>
+              <a:t> </a:t>
+            </a:r>
+            <a:endParaRPr lang="ru-RU" sz="1200" kern="1200" dirty="0">
+              <a:solidFill>
+                <a:schemeClr val="tx1"/>
+              </a:solidFill>
+              <a:effectLst/>
+              <a:latin typeface="+mn-lt"/>
+              <a:ea typeface="+mn-ea"/>
+              <a:cs typeface="+mn-cs"/>
+            </a:endParaRPr>
+          </a:p>
+          <a:p>
+            <a:r>
+              <a:rPr lang="ru-RU" sz="1200" b="1" kern="1200" dirty="0">
+                <a:solidFill>
+                  <a:schemeClr val="tx1"/>
+                </a:solidFill>
+                <a:effectLst/>
+                <a:latin typeface="+mn-lt"/>
+                <a:ea typeface="+mn-ea"/>
+                <a:cs typeface="+mn-cs"/>
+              </a:rPr>
+              <a:t>Фреймовые сети</a:t>
+            </a:r>
+            <a:r>
+              <a:rPr lang="en-US" sz="1200" b="1" kern="1200" dirty="0">
+                <a:solidFill>
+                  <a:schemeClr val="tx1"/>
+                </a:solidFill>
+                <a:effectLst/>
+                <a:latin typeface="+mn-lt"/>
+                <a:ea typeface="+mn-ea"/>
+                <a:cs typeface="+mn-cs"/>
+              </a:rPr>
+              <a:t> (Frame-Based Networks)</a:t>
+            </a:r>
+            <a:endParaRPr lang="ru-RU" sz="1200" b="1" kern="1200" dirty="0">
+              <a:solidFill>
+                <a:schemeClr val="tx1"/>
+              </a:solidFill>
+              <a:effectLst/>
+              <a:latin typeface="+mn-lt"/>
+              <a:ea typeface="+mn-ea"/>
+              <a:cs typeface="+mn-cs"/>
+            </a:endParaRPr>
+          </a:p>
+          <a:p>
+            <a:r>
+              <a:rPr lang="ru-RU" sz="1200" kern="1200" dirty="0">
+                <a:solidFill>
+                  <a:schemeClr val="tx1"/>
+                </a:solidFill>
+                <a:effectLst/>
+                <a:latin typeface="+mn-lt"/>
+                <a:ea typeface="+mn-ea"/>
+                <a:cs typeface="+mn-cs"/>
+              </a:rPr>
+              <a:t>Фреймовые сети основаны на концепции фреймов, предложенной Марвином Минским. Они используются для представления знаний о типичных сценариях, объединяя в себе несколько понятий и связей, связанных в единую структуру. В основе лежат "фреймы" — структурированные блоки, представляющие понятия и связанные с ними события, действия или характеристики.</a:t>
+            </a:r>
+          </a:p>
+          <a:p>
+            <a:r>
+              <a:rPr lang="ru-RU" sz="1200" b="1" kern="1200" dirty="0">
+                <a:solidFill>
+                  <a:schemeClr val="tx1"/>
+                </a:solidFill>
+                <a:effectLst/>
+                <a:latin typeface="+mn-lt"/>
+                <a:ea typeface="+mn-ea"/>
+                <a:cs typeface="+mn-cs"/>
+              </a:rPr>
+              <a:t>Особенности:</a:t>
+            </a:r>
+            <a:endParaRPr lang="ru-RU" sz="1200" kern="1200" dirty="0">
+              <a:solidFill>
+                <a:schemeClr val="tx1"/>
+              </a:solidFill>
+              <a:effectLst/>
+              <a:latin typeface="+mn-lt"/>
+              <a:ea typeface="+mn-ea"/>
+              <a:cs typeface="+mn-cs"/>
+            </a:endParaRPr>
+          </a:p>
+          <a:p>
+            <a:pPr lvl="0"/>
+            <a:r>
+              <a:rPr lang="ru-RU" sz="1200" kern="1200" dirty="0">
+                <a:solidFill>
+                  <a:schemeClr val="tx1"/>
+                </a:solidFill>
+                <a:effectLst/>
+                <a:latin typeface="+mn-lt"/>
+                <a:ea typeface="+mn-ea"/>
+                <a:cs typeface="+mn-cs"/>
+              </a:rPr>
+              <a:t>Фреймы включают в себя понятия, связанные с определёнными сценариями или действиями.</a:t>
+            </a:r>
+          </a:p>
+          <a:p>
+            <a:pPr lvl="0"/>
+            <a:r>
+              <a:rPr lang="ru-RU" sz="1200" kern="1200" dirty="0">
+                <a:solidFill>
+                  <a:schemeClr val="tx1"/>
+                </a:solidFill>
+                <a:effectLst/>
+                <a:latin typeface="+mn-lt"/>
+                <a:ea typeface="+mn-ea"/>
+                <a:cs typeface="+mn-cs"/>
+              </a:rPr>
+              <a:t>Каждый фрейм может содержать узлы, свойства и отношения, связанные с определённым сценарием.</a:t>
+            </a:r>
+          </a:p>
+          <a:p>
+            <a:pPr lvl="0"/>
+            <a:r>
+              <a:rPr lang="ru-RU" sz="1200" kern="1200" dirty="0">
+                <a:solidFill>
+                  <a:schemeClr val="tx1"/>
+                </a:solidFill>
+                <a:effectLst/>
+                <a:latin typeface="+mn-lt"/>
+                <a:ea typeface="+mn-ea"/>
+                <a:cs typeface="+mn-cs"/>
+              </a:rPr>
+              <a:t>Полезны для моделирования ситуационных знаний, где требуется контекстное понимание.</a:t>
+            </a:r>
+          </a:p>
+          <a:p>
+            <a:r>
+              <a:rPr lang="ru-RU" sz="1200" b="1" kern="1200" dirty="0">
+                <a:solidFill>
+                  <a:schemeClr val="tx1"/>
+                </a:solidFill>
+                <a:effectLst/>
+                <a:latin typeface="+mn-lt"/>
+                <a:ea typeface="+mn-ea"/>
+                <a:cs typeface="+mn-cs"/>
+              </a:rPr>
+              <a:t>Пример:</a:t>
+            </a:r>
+            <a:endParaRPr lang="ru-RU" sz="1200" kern="1200" dirty="0">
+              <a:solidFill>
+                <a:schemeClr val="tx1"/>
+              </a:solidFill>
+              <a:effectLst/>
+              <a:latin typeface="+mn-lt"/>
+              <a:ea typeface="+mn-ea"/>
+              <a:cs typeface="+mn-cs"/>
+            </a:endParaRPr>
+          </a:p>
+          <a:p>
+            <a:pPr lvl="0"/>
+            <a:r>
+              <a:rPr lang="ru-RU" sz="1200" kern="1200" dirty="0">
+                <a:solidFill>
+                  <a:schemeClr val="tx1"/>
+                </a:solidFill>
+                <a:effectLst/>
+                <a:latin typeface="+mn-lt"/>
+                <a:ea typeface="+mn-ea"/>
+                <a:cs typeface="+mn-cs"/>
+              </a:rPr>
+              <a:t>Фрейм "Поход в ресторан": включает узлы "Ресторан", "Меню", "Официант", "Заказ".</a:t>
+            </a:r>
+          </a:p>
+          <a:p>
+            <a:pPr lvl="0"/>
+            <a:r>
+              <a:rPr lang="ru-RU" sz="1200" kern="1200" dirty="0">
+                <a:solidFill>
+                  <a:schemeClr val="tx1"/>
+                </a:solidFill>
+                <a:effectLst/>
+                <a:latin typeface="+mn-lt"/>
+                <a:ea typeface="+mn-ea"/>
+                <a:cs typeface="+mn-cs"/>
+              </a:rPr>
+              <a:t>Связи: "Посетитель — делает заказ — Официанту", "Официант — приносит — Блюдо", "Посетитель — оплачивает — Счёт".</a:t>
+            </a:r>
+          </a:p>
+          <a:p>
+            <a:r>
+              <a:rPr lang="ru-RU" sz="1200" kern="1200" dirty="0">
+                <a:solidFill>
+                  <a:schemeClr val="tx1"/>
+                </a:solidFill>
+                <a:effectLst/>
+                <a:latin typeface="+mn-lt"/>
+                <a:ea typeface="+mn-ea"/>
+                <a:cs typeface="+mn-cs"/>
+              </a:rPr>
+              <a:t>Фреймовые сети позволяют моделировать знания о событиях и последовательностях действий, таких как посещение ресторана или выполнение медицинской процедуры.</a:t>
+            </a:r>
+          </a:p>
+          <a:p>
+            <a:r>
+              <a:rPr lang="ru-RU" sz="1200" b="1" kern="1200" dirty="0">
+                <a:solidFill>
+                  <a:schemeClr val="tx1"/>
+                </a:solidFill>
+                <a:effectLst/>
+                <a:latin typeface="+mn-lt"/>
+                <a:ea typeface="+mn-ea"/>
+                <a:cs typeface="+mn-cs"/>
+              </a:rPr>
+              <a:t> </a:t>
+            </a:r>
+            <a:endParaRPr lang="ru-RU" sz="1200" kern="1200" dirty="0">
+              <a:solidFill>
+                <a:schemeClr val="tx1"/>
+              </a:solidFill>
+              <a:effectLst/>
+              <a:latin typeface="+mn-lt"/>
+              <a:ea typeface="+mn-ea"/>
+              <a:cs typeface="+mn-cs"/>
+            </a:endParaRPr>
+          </a:p>
+          <a:p>
+            <a:r>
+              <a:rPr lang="ru-RU" sz="1200" b="1" kern="1200" dirty="0">
+                <a:solidFill>
+                  <a:schemeClr val="tx1"/>
+                </a:solidFill>
+                <a:effectLst/>
+                <a:latin typeface="+mn-lt"/>
+                <a:ea typeface="+mn-ea"/>
+                <a:cs typeface="+mn-cs"/>
+              </a:rPr>
+              <a:t>Логические семантические сети (</a:t>
+            </a:r>
+            <a:r>
+              <a:rPr lang="ru-RU" sz="1200" b="1" kern="1200" dirty="0" err="1">
+                <a:solidFill>
+                  <a:schemeClr val="tx1"/>
+                </a:solidFill>
+                <a:effectLst/>
+                <a:latin typeface="+mn-lt"/>
+                <a:ea typeface="+mn-ea"/>
+                <a:cs typeface="+mn-cs"/>
+              </a:rPr>
+              <a:t>Logical</a:t>
+            </a:r>
+            <a:r>
+              <a:rPr lang="ru-RU" sz="1200" b="1" kern="1200" dirty="0">
+                <a:solidFill>
+                  <a:schemeClr val="tx1"/>
+                </a:solidFill>
+                <a:effectLst/>
+                <a:latin typeface="+mn-lt"/>
+                <a:ea typeface="+mn-ea"/>
+                <a:cs typeface="+mn-cs"/>
+              </a:rPr>
+              <a:t> </a:t>
+            </a:r>
+            <a:r>
+              <a:rPr lang="ru-RU" sz="1200" b="1" kern="1200" dirty="0" err="1">
+                <a:solidFill>
+                  <a:schemeClr val="tx1"/>
+                </a:solidFill>
+                <a:effectLst/>
+                <a:latin typeface="+mn-lt"/>
+                <a:ea typeface="+mn-ea"/>
+                <a:cs typeface="+mn-cs"/>
+              </a:rPr>
+              <a:t>Semantic</a:t>
+            </a:r>
+            <a:r>
+              <a:rPr lang="ru-RU" sz="1200" b="1" kern="1200" dirty="0">
+                <a:solidFill>
+                  <a:schemeClr val="tx1"/>
+                </a:solidFill>
+                <a:effectLst/>
+                <a:latin typeface="+mn-lt"/>
+                <a:ea typeface="+mn-ea"/>
+                <a:cs typeface="+mn-cs"/>
+              </a:rPr>
+              <a:t> Networks)</a:t>
+            </a:r>
+          </a:p>
+          <a:p>
+            <a:r>
+              <a:rPr lang="ru-RU" sz="1200" kern="1200" dirty="0">
+                <a:solidFill>
+                  <a:schemeClr val="tx1"/>
+                </a:solidFill>
+                <a:effectLst/>
+                <a:latin typeface="+mn-lt"/>
+                <a:ea typeface="+mn-ea"/>
+                <a:cs typeface="+mn-cs"/>
+              </a:rPr>
+              <a:t>Логические сети объединяют семантические связи и формальную логику. Они включают логические правила и аксиомы, которые определяют, какие выводы могут быть сделаны на основе существующих связей. Этот тип сети используется для систем, где важно не только представлять знания, но и делать логические выводы.</a:t>
+            </a:r>
+          </a:p>
+          <a:p>
+            <a:r>
+              <a:rPr lang="ru-RU" sz="1200" b="1" kern="1200" dirty="0">
+                <a:solidFill>
+                  <a:schemeClr val="tx1"/>
+                </a:solidFill>
+                <a:effectLst/>
+                <a:latin typeface="+mn-lt"/>
+                <a:ea typeface="+mn-ea"/>
+                <a:cs typeface="+mn-cs"/>
+              </a:rPr>
+              <a:t>Особенности:</a:t>
+            </a:r>
+            <a:endParaRPr lang="ru-RU" sz="1200" kern="1200" dirty="0">
+              <a:solidFill>
+                <a:schemeClr val="tx1"/>
+              </a:solidFill>
+              <a:effectLst/>
+              <a:latin typeface="+mn-lt"/>
+              <a:ea typeface="+mn-ea"/>
+              <a:cs typeface="+mn-cs"/>
+            </a:endParaRPr>
+          </a:p>
+          <a:p>
+            <a:pPr lvl="0"/>
+            <a:r>
+              <a:rPr lang="ru-RU" sz="1200" kern="1200" dirty="0">
+                <a:solidFill>
+                  <a:schemeClr val="tx1"/>
+                </a:solidFill>
+                <a:effectLst/>
+                <a:latin typeface="+mn-lt"/>
+                <a:ea typeface="+mn-ea"/>
+                <a:cs typeface="+mn-cs"/>
+              </a:rPr>
+              <a:t>Используют логические правила для формулирования выводов.</a:t>
+            </a:r>
+          </a:p>
+          <a:p>
+            <a:pPr lvl="0"/>
+            <a:r>
+              <a:rPr lang="ru-RU" sz="1200" kern="1200" dirty="0">
+                <a:solidFill>
+                  <a:schemeClr val="tx1"/>
+                </a:solidFill>
+                <a:effectLst/>
+                <a:latin typeface="+mn-lt"/>
+                <a:ea typeface="+mn-ea"/>
+                <a:cs typeface="+mn-cs"/>
+              </a:rPr>
+              <a:t>Включают аксиомы, которые можно использовать для автоматического вывода.</a:t>
+            </a:r>
+          </a:p>
+          <a:p>
+            <a:pPr lvl="0"/>
+            <a:r>
+              <a:rPr lang="ru-RU" sz="1200" kern="1200" dirty="0">
+                <a:solidFill>
+                  <a:schemeClr val="tx1"/>
+                </a:solidFill>
+                <a:effectLst/>
+                <a:latin typeface="+mn-lt"/>
+                <a:ea typeface="+mn-ea"/>
+                <a:cs typeface="+mn-cs"/>
+              </a:rPr>
+              <a:t>Применяются в экспертных системах, где необходимо строить выводы на основе данных.</a:t>
+            </a:r>
+          </a:p>
+          <a:p>
+            <a:r>
+              <a:rPr lang="ru-RU" sz="1200" b="1" kern="1200" dirty="0">
+                <a:solidFill>
+                  <a:schemeClr val="tx1"/>
+                </a:solidFill>
+                <a:effectLst/>
+                <a:latin typeface="+mn-lt"/>
+                <a:ea typeface="+mn-ea"/>
+                <a:cs typeface="+mn-cs"/>
+              </a:rPr>
+              <a:t>Пример:</a:t>
+            </a:r>
+            <a:endParaRPr lang="ru-RU" sz="1200" kern="1200" dirty="0">
+              <a:solidFill>
+                <a:schemeClr val="tx1"/>
+              </a:solidFill>
+              <a:effectLst/>
+              <a:latin typeface="+mn-lt"/>
+              <a:ea typeface="+mn-ea"/>
+              <a:cs typeface="+mn-cs"/>
+            </a:endParaRPr>
+          </a:p>
+          <a:p>
+            <a:pPr lvl="0"/>
+            <a:r>
+              <a:rPr lang="ru-RU" sz="1200" kern="1200" dirty="0">
+                <a:solidFill>
+                  <a:schemeClr val="tx1"/>
+                </a:solidFill>
+                <a:effectLst/>
+                <a:latin typeface="+mn-lt"/>
+                <a:ea typeface="+mn-ea"/>
+                <a:cs typeface="+mn-cs"/>
+              </a:rPr>
+              <a:t>Узлы: "Человек", "Смертен", "Сократ".</a:t>
+            </a:r>
+          </a:p>
+          <a:p>
+            <a:pPr lvl="0"/>
+            <a:r>
+              <a:rPr lang="ru-RU" sz="1200" kern="1200" dirty="0">
+                <a:solidFill>
+                  <a:schemeClr val="tx1"/>
+                </a:solidFill>
+                <a:effectLst/>
+                <a:latin typeface="+mn-lt"/>
+                <a:ea typeface="+mn-ea"/>
+                <a:cs typeface="+mn-cs"/>
+              </a:rPr>
+              <a:t>Связи: "Человек — является — Смертен", "Сократ — является — Человек".</a:t>
+            </a:r>
+          </a:p>
+          <a:p>
+            <a:pPr lvl="0"/>
+            <a:r>
+              <a:rPr lang="ru-RU" sz="1200" kern="1200" dirty="0">
+                <a:solidFill>
+                  <a:schemeClr val="tx1"/>
+                </a:solidFill>
+                <a:effectLst/>
+                <a:latin typeface="+mn-lt"/>
+                <a:ea typeface="+mn-ea"/>
+                <a:cs typeface="+mn-cs"/>
+              </a:rPr>
+              <a:t>Логическое правило: если "Человек — является — Смертен", то "Сократ — Смертен".</a:t>
+            </a:r>
+          </a:p>
+          <a:p>
+            <a:r>
+              <a:rPr lang="ru-RU" sz="1200" kern="1200" dirty="0">
+                <a:solidFill>
+                  <a:schemeClr val="tx1"/>
+                </a:solidFill>
+                <a:effectLst/>
+                <a:latin typeface="+mn-lt"/>
+                <a:ea typeface="+mn-ea"/>
+                <a:cs typeface="+mn-cs"/>
+              </a:rPr>
+              <a:t>Логические сети используются в экспертных системах и базах знаний, где важно, чтобы сеть могла автоматически делать выводы на основе знаний, заложенных в ней.</a:t>
+            </a:r>
+          </a:p>
+          <a:p>
+            <a:r>
+              <a:rPr lang="ru-RU" sz="1200" kern="1200" dirty="0">
+                <a:solidFill>
+                  <a:schemeClr val="tx1"/>
+                </a:solidFill>
+                <a:effectLst/>
+                <a:latin typeface="+mn-lt"/>
+                <a:ea typeface="+mn-ea"/>
+                <a:cs typeface="+mn-cs"/>
+              </a:rPr>
+              <a:t> </a:t>
+            </a:r>
+          </a:p>
+          <a:p>
+            <a:r>
+              <a:rPr lang="ru-RU" sz="1200" kern="1200" dirty="0">
+                <a:solidFill>
+                  <a:schemeClr val="tx1"/>
+                </a:solidFill>
+                <a:effectLst/>
+                <a:latin typeface="+mn-lt"/>
+                <a:ea typeface="+mn-ea"/>
+                <a:cs typeface="+mn-cs"/>
+              </a:rPr>
+              <a:t> </a:t>
+            </a:r>
+          </a:p>
+          <a:p>
+            <a:endParaRPr lang="en-US" dirty="0"/>
+          </a:p>
+          <a:p>
             <a:endParaRPr lang="en-US" dirty="0"/>
           </a:p>
         </p:txBody>
@@ -472,6 +1170,690 @@
         <p:txBody>
           <a:bodyPr/>
           <a:lstStyle/>
+          <a:p>
+            <a:r>
+              <a:rPr lang="ru-RU" sz="1200" b="1" kern="1200" dirty="0">
+                <a:solidFill>
+                  <a:schemeClr val="tx1"/>
+                </a:solidFill>
+                <a:effectLst/>
+                <a:latin typeface="+mn-lt"/>
+                <a:ea typeface="+mn-ea"/>
+                <a:cs typeface="+mn-cs"/>
+              </a:rPr>
+              <a:t>Лингвистические базы данных (например, </a:t>
+            </a:r>
+            <a:r>
+              <a:rPr lang="ru-RU" sz="1200" b="1" kern="1200" dirty="0" err="1">
+                <a:solidFill>
+                  <a:schemeClr val="tx1"/>
+                </a:solidFill>
+                <a:effectLst/>
+                <a:latin typeface="+mn-lt"/>
+                <a:ea typeface="+mn-ea"/>
+                <a:cs typeface="+mn-cs"/>
+              </a:rPr>
+              <a:t>WordNet</a:t>
+            </a:r>
+            <a:r>
+              <a:rPr lang="ru-RU" sz="1200" b="1" kern="1200" dirty="0">
+                <a:solidFill>
+                  <a:schemeClr val="tx1"/>
+                </a:solidFill>
+                <a:effectLst/>
+                <a:latin typeface="+mn-lt"/>
+                <a:ea typeface="+mn-ea"/>
+                <a:cs typeface="+mn-cs"/>
+              </a:rPr>
+              <a:t>)</a:t>
+            </a:r>
+          </a:p>
+          <a:p>
+            <a:r>
+              <a:rPr lang="ru-RU" sz="1200" kern="1200" dirty="0" err="1">
+                <a:solidFill>
+                  <a:schemeClr val="tx1"/>
+                </a:solidFill>
+                <a:effectLst/>
+                <a:latin typeface="+mn-lt"/>
+                <a:ea typeface="+mn-ea"/>
+                <a:cs typeface="+mn-cs"/>
+              </a:rPr>
+              <a:t>WordNet</a:t>
+            </a:r>
+            <a:r>
+              <a:rPr lang="ru-RU" sz="1200" kern="1200" dirty="0">
+                <a:solidFill>
+                  <a:schemeClr val="tx1"/>
+                </a:solidFill>
+                <a:effectLst/>
+                <a:latin typeface="+mn-lt"/>
+                <a:ea typeface="+mn-ea"/>
+                <a:cs typeface="+mn-cs"/>
+              </a:rPr>
+              <a:t> — это крупная лингвистическая база данных, в которой слова и их значения представлены в виде семантической сети. Эта база данных позволяет моделировать связи между словами (синонимы, антонимы, гипонимы и </a:t>
+            </a:r>
+            <a:r>
+              <a:rPr lang="ru-RU" sz="1200" kern="1200" dirty="0" err="1">
+                <a:solidFill>
+                  <a:schemeClr val="tx1"/>
+                </a:solidFill>
+                <a:effectLst/>
+                <a:latin typeface="+mn-lt"/>
+                <a:ea typeface="+mn-ea"/>
+                <a:cs typeface="+mn-cs"/>
+              </a:rPr>
+              <a:t>гиперонимы</a:t>
+            </a:r>
+            <a:r>
+              <a:rPr lang="ru-RU" sz="1200" kern="1200" dirty="0">
+                <a:solidFill>
+                  <a:schemeClr val="tx1"/>
+                </a:solidFill>
+                <a:effectLst/>
+                <a:latin typeface="+mn-lt"/>
+                <a:ea typeface="+mn-ea"/>
+                <a:cs typeface="+mn-cs"/>
+              </a:rPr>
+              <a:t>) и является полезным инструментом для исследований в области обработки языка и когнитивной психологии.</a:t>
+            </a:r>
+          </a:p>
+          <a:p>
+            <a:pPr lvl="0"/>
+            <a:r>
+              <a:rPr lang="ru-RU" sz="1200" b="1" kern="1200" dirty="0">
+                <a:solidFill>
+                  <a:schemeClr val="tx1"/>
+                </a:solidFill>
+                <a:effectLst/>
+                <a:latin typeface="+mn-lt"/>
+                <a:ea typeface="+mn-ea"/>
+                <a:cs typeface="+mn-cs"/>
+              </a:rPr>
+              <a:t>Пример использования</a:t>
+            </a:r>
+            <a:r>
+              <a:rPr lang="ru-RU" sz="1200" kern="1200" dirty="0">
+                <a:solidFill>
+                  <a:schemeClr val="tx1"/>
+                </a:solidFill>
+                <a:effectLst/>
+                <a:latin typeface="+mn-lt"/>
+                <a:ea typeface="+mn-ea"/>
+                <a:cs typeface="+mn-cs"/>
+              </a:rPr>
+              <a:t>: </a:t>
+            </a:r>
+            <a:r>
+              <a:rPr lang="ru-RU" sz="1200" kern="1200" dirty="0" err="1">
+                <a:solidFill>
+                  <a:schemeClr val="tx1"/>
+                </a:solidFill>
+                <a:effectLst/>
+                <a:latin typeface="+mn-lt"/>
+                <a:ea typeface="+mn-ea"/>
+                <a:cs typeface="+mn-cs"/>
+              </a:rPr>
+              <a:t>WordNet</a:t>
+            </a:r>
+            <a:r>
+              <a:rPr lang="ru-RU" sz="1200" kern="1200" dirty="0">
+                <a:solidFill>
+                  <a:schemeClr val="tx1"/>
+                </a:solidFill>
+                <a:effectLst/>
+                <a:latin typeface="+mn-lt"/>
+                <a:ea typeface="+mn-ea"/>
+                <a:cs typeface="+mn-cs"/>
+              </a:rPr>
+              <a:t> помогает системам NLP понимать смысл и отношения между словами. Например, система может понять, что слова "собака" и "животное" связаны и что "собака" является подтипом "животного".</a:t>
+            </a:r>
+          </a:p>
+          <a:p>
+            <a:r>
+              <a:rPr lang="ru-RU" sz="1200" kern="1200" dirty="0">
+                <a:solidFill>
+                  <a:schemeClr val="tx1"/>
+                </a:solidFill>
+                <a:effectLst/>
+                <a:latin typeface="+mn-lt"/>
+                <a:ea typeface="+mn-ea"/>
+                <a:cs typeface="+mn-cs"/>
+              </a:rPr>
+              <a:t> </a:t>
+            </a:r>
+          </a:p>
+          <a:p>
+            <a:r>
+              <a:rPr lang="ru-RU" sz="1200" b="1" kern="1200" dirty="0">
+                <a:solidFill>
+                  <a:schemeClr val="tx1"/>
+                </a:solidFill>
+                <a:effectLst/>
+                <a:latin typeface="+mn-lt"/>
+                <a:ea typeface="+mn-ea"/>
+                <a:cs typeface="+mn-cs"/>
+              </a:rPr>
+              <a:t>Образование и обучение</a:t>
+            </a:r>
+          </a:p>
+          <a:p>
+            <a:r>
+              <a:rPr lang="ru-RU" sz="1200" kern="1200" dirty="0">
+                <a:solidFill>
+                  <a:schemeClr val="tx1"/>
+                </a:solidFill>
+                <a:effectLst/>
+                <a:latin typeface="+mn-lt"/>
+                <a:ea typeface="+mn-ea"/>
+                <a:cs typeface="+mn-cs"/>
+              </a:rPr>
+              <a:t>Семантические сети активно используются в образовательных платформах и системах дистанционного обучения для построения структурированного контента и отображения связей между учебными темами. Сети помогают создавать карты знаний, которые могут помочь студентам лучше понять материал и построить логические связи между темами.</a:t>
+            </a:r>
+          </a:p>
+          <a:p>
+            <a:pPr lvl="0"/>
+            <a:r>
+              <a:rPr lang="ru-RU" sz="1200" b="1" kern="1200" dirty="0">
+                <a:solidFill>
+                  <a:schemeClr val="tx1"/>
+                </a:solidFill>
+                <a:effectLst/>
+                <a:latin typeface="+mn-lt"/>
+                <a:ea typeface="+mn-ea"/>
+                <a:cs typeface="+mn-cs"/>
+              </a:rPr>
+              <a:t>Пример использования</a:t>
+            </a:r>
+            <a:r>
+              <a:rPr lang="ru-RU" sz="1200" kern="1200" dirty="0">
+                <a:solidFill>
+                  <a:schemeClr val="tx1"/>
+                </a:solidFill>
+                <a:effectLst/>
+                <a:latin typeface="+mn-lt"/>
+                <a:ea typeface="+mn-ea"/>
+                <a:cs typeface="+mn-cs"/>
+              </a:rPr>
+              <a:t>: карта знаний, связанная с биологией, может показывать связи между такими темами, как "клетка", "ДНК", "генетика" и "организм". Это позволяет студентам видеть взаимосвязи и лучше понимать структуру предмета.</a:t>
+            </a:r>
+          </a:p>
+          <a:p>
+            <a:r>
+              <a:rPr lang="ru-RU" sz="1200" b="1" kern="1200" dirty="0">
+                <a:solidFill>
+                  <a:schemeClr val="tx1"/>
+                </a:solidFill>
+                <a:effectLst/>
+                <a:latin typeface="+mn-lt"/>
+                <a:ea typeface="+mn-ea"/>
+                <a:cs typeface="+mn-cs"/>
+              </a:rPr>
+              <a:t> </a:t>
+            </a:r>
+            <a:endParaRPr lang="ru-RU" sz="1200" kern="1200" dirty="0">
+              <a:solidFill>
+                <a:schemeClr val="tx1"/>
+              </a:solidFill>
+              <a:effectLst/>
+              <a:latin typeface="+mn-lt"/>
+              <a:ea typeface="+mn-ea"/>
+              <a:cs typeface="+mn-cs"/>
+            </a:endParaRPr>
+          </a:p>
+          <a:p>
+            <a:r>
+              <a:rPr lang="ru-RU" sz="1200" b="1" kern="1200" dirty="0">
+                <a:solidFill>
+                  <a:schemeClr val="tx1"/>
+                </a:solidFill>
+                <a:effectLst/>
+                <a:latin typeface="+mn-lt"/>
+                <a:ea typeface="+mn-ea"/>
+                <a:cs typeface="+mn-cs"/>
+              </a:rPr>
+              <a:t>Управление знаниями и базы знаний</a:t>
+            </a:r>
+          </a:p>
+          <a:p>
+            <a:r>
+              <a:rPr lang="ru-RU" sz="1200" kern="1200" dirty="0">
+                <a:solidFill>
+                  <a:schemeClr val="tx1"/>
+                </a:solidFill>
+                <a:effectLst/>
+                <a:latin typeface="+mn-lt"/>
+                <a:ea typeface="+mn-ea"/>
+                <a:cs typeface="+mn-cs"/>
+              </a:rPr>
+              <a:t>Семантические сети играют важную роль в корпоративных базах знаний и системах управления знаниями, где требуется систематизировать и структурировать информацию. Такие системы позволяют организациям организовывать информацию, облегчая поиск и предоставление данных сотрудникам.</a:t>
+            </a:r>
+          </a:p>
+          <a:p>
+            <a:pPr lvl="0"/>
+            <a:r>
+              <a:rPr lang="ru-RU" sz="1200" b="1" kern="1200" dirty="0">
+                <a:solidFill>
+                  <a:schemeClr val="tx1"/>
+                </a:solidFill>
+                <a:effectLst/>
+                <a:latin typeface="+mn-lt"/>
+                <a:ea typeface="+mn-ea"/>
+                <a:cs typeface="+mn-cs"/>
+              </a:rPr>
+              <a:t>Пример использования</a:t>
+            </a:r>
+            <a:r>
+              <a:rPr lang="ru-RU" sz="1200" kern="1200" dirty="0">
+                <a:solidFill>
+                  <a:schemeClr val="tx1"/>
+                </a:solidFill>
+                <a:effectLst/>
+                <a:latin typeface="+mn-lt"/>
+                <a:ea typeface="+mn-ea"/>
+                <a:cs typeface="+mn-cs"/>
+              </a:rPr>
+              <a:t>: в компании могут использоваться семантические сети для связей между проектами, клиентами и документами. Если сотруднику нужно найти информацию о проекте, он может сразу увидеть, какие клиенты, задачи и документы связаны с ним.</a:t>
+            </a:r>
+          </a:p>
+          <a:p>
+            <a:r>
+              <a:rPr lang="ru-RU" sz="1200" b="1" kern="1200" dirty="0">
+                <a:solidFill>
+                  <a:schemeClr val="tx1"/>
+                </a:solidFill>
+                <a:effectLst/>
+                <a:latin typeface="+mn-lt"/>
+                <a:ea typeface="+mn-ea"/>
+                <a:cs typeface="+mn-cs"/>
+              </a:rPr>
+              <a:t> </a:t>
+            </a:r>
+            <a:endParaRPr lang="ru-RU" sz="1200" kern="1200" dirty="0">
+              <a:solidFill>
+                <a:schemeClr val="tx1"/>
+              </a:solidFill>
+              <a:effectLst/>
+              <a:latin typeface="+mn-lt"/>
+              <a:ea typeface="+mn-ea"/>
+              <a:cs typeface="+mn-cs"/>
+            </a:endParaRPr>
+          </a:p>
+          <a:p>
+            <a:r>
+              <a:rPr lang="ru-RU" sz="1200" kern="1200" dirty="0">
+                <a:solidFill>
+                  <a:schemeClr val="tx1"/>
+                </a:solidFill>
+                <a:effectLst/>
+                <a:latin typeface="+mn-lt"/>
+                <a:ea typeface="+mn-ea"/>
+                <a:cs typeface="+mn-cs"/>
+              </a:rPr>
+              <a:t> </a:t>
+            </a:r>
+          </a:p>
+          <a:p>
+            <a:r>
+              <a:rPr lang="ru-RU" sz="1200" b="1" kern="1200" dirty="0">
+                <a:solidFill>
+                  <a:schemeClr val="tx1"/>
+                </a:solidFill>
+                <a:effectLst/>
+                <a:latin typeface="+mn-lt"/>
+                <a:ea typeface="+mn-ea"/>
+                <a:cs typeface="+mn-cs"/>
+              </a:rPr>
+              <a:t>Биология и медицина</a:t>
+            </a:r>
+          </a:p>
+          <a:p>
+            <a:r>
+              <a:rPr lang="ru-RU" sz="1200" kern="1200" dirty="0">
+                <a:solidFill>
+                  <a:schemeClr val="tx1"/>
+                </a:solidFill>
+                <a:effectLst/>
+                <a:latin typeface="+mn-lt"/>
+                <a:ea typeface="+mn-ea"/>
+                <a:cs typeface="+mn-cs"/>
+              </a:rPr>
+              <a:t>В медицине и биологии семантические сети используются для отображения сложных связей между биологическими понятиями, такими как гены, болезни, симптомы и методы лечения. Семантические сети позволяют учёным и медикам находить связи между генетическими мутациями и болезнями, а также разрабатывать новые методы лечения.</a:t>
+            </a:r>
+          </a:p>
+          <a:p>
+            <a:pPr lvl="0"/>
+            <a:r>
+              <a:rPr lang="ru-RU" sz="1200" b="1" kern="1200" dirty="0">
+                <a:solidFill>
+                  <a:schemeClr val="tx1"/>
+                </a:solidFill>
+                <a:effectLst/>
+                <a:latin typeface="+mn-lt"/>
+                <a:ea typeface="+mn-ea"/>
+                <a:cs typeface="+mn-cs"/>
+              </a:rPr>
+              <a:t>Пример использования</a:t>
+            </a:r>
+            <a:r>
+              <a:rPr lang="ru-RU" sz="1200" kern="1200" dirty="0">
+                <a:solidFill>
+                  <a:schemeClr val="tx1"/>
+                </a:solidFill>
+                <a:effectLst/>
+                <a:latin typeface="+mn-lt"/>
+                <a:ea typeface="+mn-ea"/>
+                <a:cs typeface="+mn-cs"/>
+              </a:rPr>
+              <a:t>: </a:t>
+            </a:r>
+            <a:r>
+              <a:rPr lang="ru-RU" sz="1200" b="1" kern="1200" dirty="0" err="1">
+                <a:solidFill>
+                  <a:schemeClr val="tx1"/>
+                </a:solidFill>
+                <a:effectLst/>
+                <a:latin typeface="+mn-lt"/>
+                <a:ea typeface="+mn-ea"/>
+                <a:cs typeface="+mn-cs"/>
+              </a:rPr>
+              <a:t>Gene</a:t>
+            </a:r>
+            <a:r>
+              <a:rPr lang="ru-RU" sz="1200" b="1" kern="1200" dirty="0">
+                <a:solidFill>
+                  <a:schemeClr val="tx1"/>
+                </a:solidFill>
+                <a:effectLst/>
+                <a:latin typeface="+mn-lt"/>
+                <a:ea typeface="+mn-ea"/>
+                <a:cs typeface="+mn-cs"/>
+              </a:rPr>
+              <a:t> </a:t>
+            </a:r>
+            <a:r>
+              <a:rPr lang="ru-RU" sz="1200" b="1" kern="1200" dirty="0" err="1">
+                <a:solidFill>
+                  <a:schemeClr val="tx1"/>
+                </a:solidFill>
+                <a:effectLst/>
+                <a:latin typeface="+mn-lt"/>
+                <a:ea typeface="+mn-ea"/>
+                <a:cs typeface="+mn-cs"/>
+              </a:rPr>
+              <a:t>Ontology</a:t>
+            </a:r>
+            <a:r>
+              <a:rPr lang="ru-RU" sz="1200" kern="1200" dirty="0">
+                <a:solidFill>
+                  <a:schemeClr val="tx1"/>
+                </a:solidFill>
+                <a:effectLst/>
+                <a:latin typeface="+mn-lt"/>
+                <a:ea typeface="+mn-ea"/>
+                <a:cs typeface="+mn-cs"/>
+              </a:rPr>
+              <a:t> — крупная биологическая семантическая сеть, представляющая связи между генами, их функциями и связанными процессами. Она используется для исследований в генетике, биоинформатике и разработке лекарств.</a:t>
+            </a:r>
+          </a:p>
+          <a:p>
+            <a:r>
+              <a:rPr lang="ru-RU" sz="1200" b="1" kern="1200" dirty="0">
+                <a:solidFill>
+                  <a:schemeClr val="tx1"/>
+                </a:solidFill>
+                <a:effectLst/>
+                <a:latin typeface="+mn-lt"/>
+                <a:ea typeface="+mn-ea"/>
+                <a:cs typeface="+mn-cs"/>
+              </a:rPr>
+              <a:t> </a:t>
+            </a:r>
+            <a:endParaRPr lang="ru-RU" sz="1200" kern="1200" dirty="0">
+              <a:solidFill>
+                <a:schemeClr val="tx1"/>
+              </a:solidFill>
+              <a:effectLst/>
+              <a:latin typeface="+mn-lt"/>
+              <a:ea typeface="+mn-ea"/>
+              <a:cs typeface="+mn-cs"/>
+            </a:endParaRPr>
+          </a:p>
+          <a:p>
+            <a:r>
+              <a:rPr lang="ru-RU" sz="1200" b="1" kern="1200" dirty="0">
+                <a:solidFill>
+                  <a:schemeClr val="tx1"/>
+                </a:solidFill>
+                <a:effectLst/>
+                <a:latin typeface="+mn-lt"/>
+                <a:ea typeface="+mn-ea"/>
+                <a:cs typeface="+mn-cs"/>
+              </a:rPr>
+              <a:t>Интернет вещей (</a:t>
+            </a:r>
+            <a:r>
+              <a:rPr lang="ru-RU" sz="1200" b="1" kern="1200" dirty="0" err="1">
+                <a:solidFill>
+                  <a:schemeClr val="tx1"/>
+                </a:solidFill>
+                <a:effectLst/>
+                <a:latin typeface="+mn-lt"/>
+                <a:ea typeface="+mn-ea"/>
+                <a:cs typeface="+mn-cs"/>
+              </a:rPr>
+              <a:t>IoT</a:t>
+            </a:r>
+            <a:r>
+              <a:rPr lang="ru-RU" sz="1200" b="1" kern="1200" dirty="0">
+                <a:solidFill>
+                  <a:schemeClr val="tx1"/>
+                </a:solidFill>
+                <a:effectLst/>
+                <a:latin typeface="+mn-lt"/>
+                <a:ea typeface="+mn-ea"/>
+                <a:cs typeface="+mn-cs"/>
+              </a:rPr>
+              <a:t>)</a:t>
+            </a:r>
+          </a:p>
+          <a:p>
+            <a:r>
+              <a:rPr lang="ru-RU" sz="1200" kern="1200" dirty="0">
+                <a:solidFill>
+                  <a:schemeClr val="tx1"/>
+                </a:solidFill>
+                <a:effectLst/>
+                <a:latin typeface="+mn-lt"/>
+                <a:ea typeface="+mn-ea"/>
+                <a:cs typeface="+mn-cs"/>
+              </a:rPr>
+              <a:t>В области Интернета вещей (</a:t>
+            </a:r>
+            <a:r>
+              <a:rPr lang="ru-RU" sz="1200" kern="1200" dirty="0" err="1">
+                <a:solidFill>
+                  <a:schemeClr val="tx1"/>
+                </a:solidFill>
+                <a:effectLst/>
+                <a:latin typeface="+mn-lt"/>
+                <a:ea typeface="+mn-ea"/>
+                <a:cs typeface="+mn-cs"/>
+              </a:rPr>
+              <a:t>IoT</a:t>
+            </a:r>
+            <a:r>
+              <a:rPr lang="ru-RU" sz="1200" kern="1200" dirty="0">
+                <a:solidFill>
+                  <a:schemeClr val="tx1"/>
+                </a:solidFill>
+                <a:effectLst/>
+                <a:latin typeface="+mn-lt"/>
+                <a:ea typeface="+mn-ea"/>
+                <a:cs typeface="+mn-cs"/>
+              </a:rPr>
+              <a:t>) семантические сети помогают связывать и структурировать данные, поступающие от множества устройств. Сети позволяют организовывать и анализировать данные, передаваемые устройствами, и принимать решения на основе их связей и значений.</a:t>
+            </a:r>
+          </a:p>
+          <a:p>
+            <a:pPr lvl="0"/>
+            <a:r>
+              <a:rPr lang="ru-RU" sz="1200" b="1" kern="1200" dirty="0">
+                <a:solidFill>
+                  <a:schemeClr val="tx1"/>
+                </a:solidFill>
+                <a:effectLst/>
+                <a:latin typeface="+mn-lt"/>
+                <a:ea typeface="+mn-ea"/>
+                <a:cs typeface="+mn-cs"/>
+              </a:rPr>
+              <a:t>Пример использования</a:t>
+            </a:r>
+            <a:r>
+              <a:rPr lang="ru-RU" sz="1200" kern="1200" dirty="0">
+                <a:solidFill>
+                  <a:schemeClr val="tx1"/>
+                </a:solidFill>
+                <a:effectLst/>
+                <a:latin typeface="+mn-lt"/>
+                <a:ea typeface="+mn-ea"/>
+                <a:cs typeface="+mn-cs"/>
+              </a:rPr>
+              <a:t>: сеть умного дома может связывать данные от различных устройств, таких как термостаты, камеры и датчики движения. Семантическая сеть позволяет анализировать данные и автоматически регулировать температуру, освещение и безопасность в доме в зависимости от ситуации.</a:t>
+            </a:r>
+          </a:p>
+          <a:p>
+            <a:r>
+              <a:rPr lang="ru-RU" sz="1200" b="1" kern="1200" dirty="0">
+                <a:solidFill>
+                  <a:schemeClr val="tx1"/>
+                </a:solidFill>
+                <a:effectLst/>
+                <a:latin typeface="+mn-lt"/>
+                <a:ea typeface="+mn-ea"/>
+                <a:cs typeface="+mn-cs"/>
+              </a:rPr>
+              <a:t> </a:t>
+            </a:r>
+            <a:endParaRPr lang="ru-RU" sz="1200" kern="1200" dirty="0">
+              <a:solidFill>
+                <a:schemeClr val="tx1"/>
+              </a:solidFill>
+              <a:effectLst/>
+              <a:latin typeface="+mn-lt"/>
+              <a:ea typeface="+mn-ea"/>
+              <a:cs typeface="+mn-cs"/>
+            </a:endParaRPr>
+          </a:p>
+          <a:p>
+            <a:r>
+              <a:rPr lang="ru-RU" sz="1200" b="1" kern="1200" dirty="0">
+                <a:solidFill>
+                  <a:schemeClr val="tx1"/>
+                </a:solidFill>
+                <a:effectLst/>
+                <a:latin typeface="+mn-lt"/>
+                <a:ea typeface="+mn-ea"/>
+                <a:cs typeface="+mn-cs"/>
+              </a:rPr>
+              <a:t>Социальные сети и анализ данных</a:t>
+            </a:r>
+          </a:p>
+          <a:p>
+            <a:r>
+              <a:rPr lang="ru-RU" sz="1200" kern="1200" dirty="0">
+                <a:solidFill>
+                  <a:schemeClr val="tx1"/>
+                </a:solidFill>
+                <a:effectLst/>
+                <a:latin typeface="+mn-lt"/>
+                <a:ea typeface="+mn-ea"/>
+                <a:cs typeface="+mn-cs"/>
+              </a:rPr>
+              <a:t>Семантические сети широко применяются для анализа социальных сетей и изучения связей между пользователями, интересами и взаимодействиями. Они позволяют отслеживать связи между пользователями, анализировать распространение информации и находить ключевых участников сети.</a:t>
+            </a:r>
+          </a:p>
+          <a:p>
+            <a:pPr lvl="0"/>
+            <a:r>
+              <a:rPr lang="ru-RU" sz="1200" b="1" kern="1200" dirty="0">
+                <a:solidFill>
+                  <a:schemeClr val="tx1"/>
+                </a:solidFill>
+                <a:effectLst/>
+                <a:latin typeface="+mn-lt"/>
+                <a:ea typeface="+mn-ea"/>
+                <a:cs typeface="+mn-cs"/>
+              </a:rPr>
+              <a:t>Пример использования</a:t>
+            </a:r>
+            <a:r>
+              <a:rPr lang="ru-RU" sz="1200" kern="1200" dirty="0">
+                <a:solidFill>
+                  <a:schemeClr val="tx1"/>
+                </a:solidFill>
+                <a:effectLst/>
+                <a:latin typeface="+mn-lt"/>
+                <a:ea typeface="+mn-ea"/>
+                <a:cs typeface="+mn-cs"/>
+              </a:rPr>
+              <a:t>: в социальной сети Facebook семантическая сеть может быть использована для анализа друзей, интересов и взаимодействий. Например, если человек интересуется спортом и у него много друзей с аналогичными интересами, система может рекомендовать ему группы или события, связанные со спортом.</a:t>
+            </a:r>
+          </a:p>
+          <a:p>
+            <a:r>
+              <a:rPr lang="ru-RU" sz="1200" b="1" kern="1200" dirty="0">
+                <a:solidFill>
+                  <a:schemeClr val="tx1"/>
+                </a:solidFill>
+                <a:effectLst/>
+                <a:latin typeface="+mn-lt"/>
+                <a:ea typeface="+mn-ea"/>
+                <a:cs typeface="+mn-cs"/>
+              </a:rPr>
+              <a:t> </a:t>
+            </a:r>
+            <a:endParaRPr lang="ru-RU" sz="1200" kern="1200" dirty="0">
+              <a:solidFill>
+                <a:schemeClr val="tx1"/>
+              </a:solidFill>
+              <a:effectLst/>
+              <a:latin typeface="+mn-lt"/>
+              <a:ea typeface="+mn-ea"/>
+              <a:cs typeface="+mn-cs"/>
+            </a:endParaRPr>
+          </a:p>
+          <a:p>
+            <a:r>
+              <a:rPr lang="ru-RU" sz="1200" kern="1200" dirty="0">
+                <a:solidFill>
+                  <a:schemeClr val="tx1"/>
+                </a:solidFill>
+                <a:effectLst/>
+                <a:latin typeface="+mn-lt"/>
+                <a:ea typeface="+mn-ea"/>
+                <a:cs typeface="+mn-cs"/>
+              </a:rPr>
+              <a:t>Семантические сети находят применение в различных областях, от медицины и управления знаниями до социальных сетей и рекомендательных систем. Эти сети позволяют не только хранить знания, но и выявлять связи, делать выводы и находить скрытые паттерны в данных. Благодаря своей гибкости и способности моделировать сложные связи, семантические сети становятся важным инструментом для работы с большими данными и построения интеллектуальных систем, способных понимать и интерпретировать информацию.</a:t>
+            </a:r>
+          </a:p>
+          <a:p>
+            <a:r>
+              <a:rPr lang="ru-RU" sz="1200" kern="1200" dirty="0">
+                <a:solidFill>
+                  <a:schemeClr val="tx1"/>
+                </a:solidFill>
+                <a:effectLst/>
+                <a:latin typeface="+mn-lt"/>
+                <a:ea typeface="+mn-ea"/>
+                <a:cs typeface="+mn-cs"/>
+              </a:rPr>
+              <a:t> </a:t>
+            </a:r>
+          </a:p>
+          <a:p>
+            <a:endParaRPr lang="en-US"/>
+          </a:p>
           <a:p>
             <a:endParaRPr lang="en-US" dirty="0"/>
           </a:p>
@@ -2608,6 +3990,289 @@
         <p:txBody>
           <a:bodyPr/>
           <a:lstStyle/>
+          <a:p>
+            <a:pPr lvl="0"/>
+            <a:r>
+              <a:rPr lang="ru-RU" sz="1200" b="1" kern="1200" dirty="0">
+                <a:solidFill>
+                  <a:schemeClr val="tx1"/>
+                </a:solidFill>
+                <a:effectLst/>
+                <a:latin typeface="+mn-lt"/>
+                <a:ea typeface="+mn-ea"/>
+                <a:cs typeface="+mn-cs"/>
+              </a:rPr>
+              <a:t>Семантические связи</a:t>
+            </a:r>
+            <a:r>
+              <a:rPr lang="ru-RU" sz="1200" kern="1200" dirty="0">
+                <a:solidFill>
+                  <a:schemeClr val="tx1"/>
+                </a:solidFill>
+                <a:effectLst/>
+                <a:latin typeface="+mn-lt"/>
+                <a:ea typeface="+mn-ea"/>
+                <a:cs typeface="+mn-cs"/>
+              </a:rPr>
+              <a:t>: показывают значения или концептуальные отношения между понятиями. Например, связь между "Собака" и "Млекопитающее" может указывать на иерархическую связь вида и типа.</a:t>
+            </a:r>
+          </a:p>
+          <a:p>
+            <a:pPr lvl="0"/>
+            <a:r>
+              <a:rPr lang="ru-RU" sz="1200" b="1" kern="1200" dirty="0">
+                <a:solidFill>
+                  <a:schemeClr val="tx1"/>
+                </a:solidFill>
+                <a:effectLst/>
+                <a:latin typeface="+mn-lt"/>
+                <a:ea typeface="+mn-ea"/>
+                <a:cs typeface="+mn-cs"/>
+              </a:rPr>
+              <a:t>Ассоциативные связи</a:t>
+            </a:r>
+            <a:r>
+              <a:rPr lang="ru-RU" sz="1200" kern="1200" dirty="0">
+                <a:solidFill>
+                  <a:schemeClr val="tx1"/>
+                </a:solidFill>
+                <a:effectLst/>
+                <a:latin typeface="+mn-lt"/>
+                <a:ea typeface="+mn-ea"/>
+                <a:cs typeface="+mn-cs"/>
+              </a:rPr>
+              <a:t>: связи, которые могут отражать ассоциации или сходства, не обязательно строго иерархические. Например, "Солнце — связано с — Свет".</a:t>
+            </a:r>
+          </a:p>
+          <a:p>
+            <a:r>
+              <a:rPr lang="ru-RU" sz="1200" b="1" kern="1200" dirty="0">
+                <a:solidFill>
+                  <a:schemeClr val="tx1"/>
+                </a:solidFill>
+                <a:effectLst/>
+                <a:latin typeface="+mn-lt"/>
+                <a:ea typeface="+mn-ea"/>
+                <a:cs typeface="+mn-cs"/>
+              </a:rPr>
+              <a:t>Функциональные связи</a:t>
+            </a:r>
+            <a:r>
+              <a:rPr lang="ru-RU" sz="1200" kern="1200" dirty="0">
+                <a:solidFill>
+                  <a:schemeClr val="tx1"/>
+                </a:solidFill>
+                <a:effectLst/>
+                <a:latin typeface="+mn-lt"/>
+                <a:ea typeface="+mn-ea"/>
+                <a:cs typeface="+mn-cs"/>
+              </a:rPr>
+              <a:t>: показывают зависимости между объектами и действиями, например, "Пилот управляет Самолетом".</a:t>
+            </a:r>
+            <a:r>
+              <a:rPr lang="ru-RU" dirty="0">
+                <a:effectLst/>
+              </a:rPr>
+              <a:t> </a:t>
+            </a:r>
+            <a:endParaRPr lang="en-US" dirty="0">
+              <a:effectLst/>
+            </a:endParaRPr>
+          </a:p>
+          <a:p>
+            <a:endParaRPr lang="en-US" dirty="0">
+              <a:effectLst/>
+            </a:endParaRPr>
+          </a:p>
+          <a:p>
+            <a:r>
+              <a:rPr lang="ru-RU" sz="1200" b="1" kern="1200" dirty="0">
+                <a:solidFill>
+                  <a:schemeClr val="tx1"/>
+                </a:solidFill>
+                <a:effectLst/>
+                <a:latin typeface="+mn-lt"/>
+                <a:ea typeface="+mn-ea"/>
+                <a:cs typeface="+mn-cs"/>
+              </a:rPr>
+              <a:t>Иерархия понятий и наследование</a:t>
+            </a:r>
+          </a:p>
+          <a:p>
+            <a:r>
+              <a:rPr lang="ru-RU" sz="1200" kern="1200" dirty="0">
+                <a:solidFill>
+                  <a:schemeClr val="tx1"/>
+                </a:solidFill>
+                <a:effectLst/>
+                <a:latin typeface="+mn-lt"/>
+                <a:ea typeface="+mn-ea"/>
+                <a:cs typeface="+mn-cs"/>
+              </a:rPr>
+              <a:t>Семантические сети часто включают иерархические отношения, которые определяют, как понятия расположены относительно друг друга. Например, "Млекопитающие" могут быть родительским узлом для понятий "Кошка" и "Собака". В такой иерархии понятия нижнего уровня наследуют свойства более высоких понятий. Если на уровне "Млекопитающие" задано свойство "теплокровные", то и "Кошка", и "Собака" также будут иметь это свойство.</a:t>
+            </a:r>
+          </a:p>
+          <a:p>
+            <a:r>
+              <a:rPr lang="ru-RU" sz="1200" kern="1200" dirty="0">
+                <a:solidFill>
+                  <a:schemeClr val="tx1"/>
+                </a:solidFill>
+                <a:effectLst/>
+                <a:latin typeface="+mn-lt"/>
+                <a:ea typeface="+mn-ea"/>
+                <a:cs typeface="+mn-cs"/>
+              </a:rPr>
+              <a:t>Наследование в иерархии позволяет упростить создание сети, так как общие свойства задаются один раз на уровне родительских понятий и автоматически наследуются дочерними узлами. Это также делает сеть более гибкой для добавления новых понятий и отношений.</a:t>
+            </a:r>
+          </a:p>
+          <a:p>
+            <a:r>
+              <a:rPr lang="ru-RU" sz="1200" b="1" kern="1200" dirty="0">
+                <a:solidFill>
+                  <a:schemeClr val="tx1"/>
+                </a:solidFill>
+                <a:effectLst/>
+                <a:latin typeface="+mn-lt"/>
+                <a:ea typeface="+mn-ea"/>
+                <a:cs typeface="+mn-cs"/>
+              </a:rPr>
+              <a:t> </a:t>
+            </a:r>
+            <a:endParaRPr lang="ru-RU" sz="1200" kern="1200" dirty="0">
+              <a:solidFill>
+                <a:schemeClr val="tx1"/>
+              </a:solidFill>
+              <a:effectLst/>
+              <a:latin typeface="+mn-lt"/>
+              <a:ea typeface="+mn-ea"/>
+              <a:cs typeface="+mn-cs"/>
+            </a:endParaRPr>
+          </a:p>
+          <a:p>
+            <a:r>
+              <a:rPr lang="ru-RU" sz="1200" b="1" kern="1200" dirty="0">
+                <a:solidFill>
+                  <a:schemeClr val="tx1"/>
+                </a:solidFill>
+                <a:effectLst/>
+                <a:latin typeface="+mn-lt"/>
+                <a:ea typeface="+mn-ea"/>
+                <a:cs typeface="+mn-cs"/>
+              </a:rPr>
+              <a:t>Примеры использования основных элементов семантической сети</a:t>
+            </a:r>
+          </a:p>
+          <a:p>
+            <a:r>
+              <a:rPr lang="ru-RU" sz="1200" kern="1200" dirty="0">
+                <a:solidFill>
+                  <a:schemeClr val="tx1"/>
+                </a:solidFill>
+                <a:effectLst/>
+                <a:latin typeface="+mn-lt"/>
+                <a:ea typeface="+mn-ea"/>
+                <a:cs typeface="+mn-cs"/>
+              </a:rPr>
+              <a:t>Семантические сети применяются во многих системах, таких как поисковые движки, базы знаний, системы распознавания речи, системы обработки естественного языка и многие другие.</a:t>
+            </a:r>
+          </a:p>
+          <a:p>
+            <a:r>
+              <a:rPr lang="ru-RU" sz="1200" kern="1200" dirty="0">
+                <a:solidFill>
+                  <a:schemeClr val="tx1"/>
+                </a:solidFill>
+                <a:effectLst/>
+                <a:latin typeface="+mn-lt"/>
+                <a:ea typeface="+mn-ea"/>
+                <a:cs typeface="+mn-cs"/>
+              </a:rPr>
+              <a:t>Пример семантической сети в системе поиска:</a:t>
+            </a:r>
+          </a:p>
+          <a:p>
+            <a:pPr lvl="0"/>
+            <a:r>
+              <a:rPr lang="ru-RU" sz="1200" kern="1200" dirty="0">
+                <a:solidFill>
+                  <a:schemeClr val="tx1"/>
+                </a:solidFill>
+                <a:effectLst/>
+                <a:latin typeface="+mn-lt"/>
+                <a:ea typeface="+mn-ea"/>
+                <a:cs typeface="+mn-cs"/>
+              </a:rPr>
+              <a:t>Узлы: "Человек", "Книга", "Автор", "Жанр".</a:t>
+            </a:r>
+          </a:p>
+          <a:p>
+            <a:pPr lvl="0"/>
+            <a:r>
+              <a:rPr lang="ru-RU" sz="1200" kern="1200" dirty="0">
+                <a:solidFill>
+                  <a:schemeClr val="tx1"/>
+                </a:solidFill>
+                <a:effectLst/>
+                <a:latin typeface="+mn-lt"/>
+                <a:ea typeface="+mn-ea"/>
+                <a:cs typeface="+mn-cs"/>
+              </a:rPr>
+              <a:t>Связи: "Человек — читает — Книга", "Книга — написана — Автором", "Книга — принадлежит к — Жанру".</a:t>
+            </a:r>
+          </a:p>
+          <a:p>
+            <a:pPr lvl="0"/>
+            <a:r>
+              <a:rPr lang="ru-RU" sz="1200" kern="1200" dirty="0">
+                <a:solidFill>
+                  <a:schemeClr val="tx1"/>
+                </a:solidFill>
+                <a:effectLst/>
+                <a:latin typeface="+mn-lt"/>
+                <a:ea typeface="+mn-ea"/>
+                <a:cs typeface="+mn-cs"/>
+              </a:rPr>
+              <a:t>Атрибуты: для узла "Книга" атрибуты могут включать "Название", "Дата издания"; для узла "Человек" — "Имя", "Возраст".</a:t>
+            </a:r>
+          </a:p>
+          <a:p>
+            <a:r>
+              <a:rPr lang="ru-RU" sz="1200" b="1" kern="1200" dirty="0">
+                <a:solidFill>
+                  <a:schemeClr val="tx1"/>
+                </a:solidFill>
+                <a:effectLst/>
+                <a:latin typeface="+mn-lt"/>
+                <a:ea typeface="+mn-ea"/>
+                <a:cs typeface="+mn-cs"/>
+              </a:rPr>
+              <a:t> </a:t>
+            </a:r>
+            <a:endParaRPr lang="ru-RU" sz="1200" kern="1200" dirty="0">
+              <a:solidFill>
+                <a:schemeClr val="tx1"/>
+              </a:solidFill>
+              <a:effectLst/>
+              <a:latin typeface="+mn-lt"/>
+              <a:ea typeface="+mn-ea"/>
+              <a:cs typeface="+mn-cs"/>
+            </a:endParaRPr>
+          </a:p>
+          <a:p>
+            <a:r>
+              <a:rPr lang="ru-RU" sz="1200" kern="1200" dirty="0">
+                <a:solidFill>
+                  <a:schemeClr val="tx1"/>
+                </a:solidFill>
+                <a:effectLst/>
+                <a:latin typeface="+mn-lt"/>
+                <a:ea typeface="+mn-ea"/>
+                <a:cs typeface="+mn-cs"/>
+              </a:rPr>
+              <a:t>Семантические сети являются мощным инструментом для моделирования сложных связей между объектами, позволяя системам эффективно представлять знания и выполнять интеллектуальный поиск. Основные элементы семантической сети — узлы, связи, атрибуты и иерархия — обеспечивают гибкость и масштабируемость, что позволяет использовать их в различных областях, от искусственного интеллекта до когнитивных наук.</a:t>
+            </a:r>
+          </a:p>
           <a:p>
             <a:endParaRPr lang="en-US" dirty="0"/>
           </a:p>
@@ -12773,7 +14438,7 @@
         </p:nvSpPr>
         <p:spPr>
           <a:xfrm>
-            <a:off x="370665" y="3044857"/>
+            <a:off x="363521" y="2772741"/>
             <a:ext cx="2510028" cy="1392650"/>
           </a:xfrm>
           <a:prstGeom prst="rect">
@@ -12812,7 +14477,7 @@
         </p:nvSpPr>
         <p:spPr>
           <a:xfrm>
-            <a:off x="3278743" y="3061335"/>
+            <a:off x="3278719" y="2756929"/>
             <a:ext cx="2586561" cy="1322832"/>
           </a:xfrm>
           <a:prstGeom prst="rect">
@@ -12851,7 +14516,7 @@
         </p:nvSpPr>
         <p:spPr>
           <a:xfrm>
-            <a:off x="6208871" y="3032188"/>
+            <a:off x="6201703" y="2756929"/>
             <a:ext cx="2594086" cy="1318498"/>
           </a:xfrm>
           <a:prstGeom prst="rect">
@@ -12884,63 +14549,256 @@
       </p:sp>
       <p:sp>
         <p:nvSpPr>
-          <p:cNvPr id="14" name="StaticPath"/>
-          <p:cNvSpPr/>
-          <p:nvPr/>
-        </p:nvSpPr>
-        <p:spPr>
-          <a:xfrm>
-            <a:off x="782002" y="4619625"/>
-            <a:ext cx="1685925" cy="71438"/>
-          </a:xfrm>
-          <a:prstGeom prst="rect">
-            <a:avLst/>
-          </a:prstGeom>
-          <a:solidFill>
-            <a:srgbClr val="FF9800"/>
-          </a:solidFill>
-          <a:ln/>
-        </p:spPr>
-      </p:sp>
-      <p:sp>
-        <p:nvSpPr>
-          <p:cNvPr id="15" name="StaticPath"/>
-          <p:cNvSpPr/>
-          <p:nvPr/>
-        </p:nvSpPr>
-        <p:spPr>
-          <a:xfrm>
-            <a:off x="3729038" y="4619625"/>
-            <a:ext cx="1685925" cy="71438"/>
-          </a:xfrm>
-          <a:prstGeom prst="rect">
-            <a:avLst/>
-          </a:prstGeom>
-          <a:solidFill>
-            <a:srgbClr val="FF9800"/>
-          </a:solidFill>
-          <a:ln/>
-        </p:spPr>
-      </p:sp>
-      <p:sp>
-        <p:nvSpPr>
-          <p:cNvPr id="16" name="StaticPath"/>
-          <p:cNvSpPr/>
-          <p:nvPr/>
-        </p:nvSpPr>
-        <p:spPr>
-          <a:xfrm>
-            <a:off x="6662928" y="4619625"/>
-            <a:ext cx="1685925" cy="71438"/>
-          </a:xfrm>
-          <a:prstGeom prst="rect">
-            <a:avLst/>
-          </a:prstGeom>
-          <a:solidFill>
-            <a:srgbClr val="FF9800"/>
-          </a:solidFill>
-          <a:ln/>
-        </p:spPr>
+          <p:cNvPr id="18" name="TextBox 17">
+            <a:extLst>
+              <a:ext uri="{FF2B5EF4-FFF2-40B4-BE49-F238E27FC236}">
+                <a16:creationId xmlns:a16="http://schemas.microsoft.com/office/drawing/2014/main" id="{F1BCCE24-9990-7B42-AAD6-5E2C79FFAD26}"/>
+              </a:ext>
+            </a:extLst>
+          </p:cNvPr>
+          <p:cNvSpPr txBox="1"/>
+          <p:nvPr/>
+        </p:nvSpPr>
+        <p:spPr>
+          <a:xfrm>
+            <a:off x="120206" y="3940873"/>
+            <a:ext cx="3043124" cy="1077218"/>
+          </a:xfrm>
+          <a:prstGeom prst="rect">
+            <a:avLst/>
+          </a:prstGeom>
+          <a:noFill/>
+        </p:spPr>
+        <p:txBody>
+          <a:bodyPr wrap="square">
+            <a:spAutoFit/>
+          </a:bodyPr>
+          <a:lstStyle/>
+          <a:p>
+            <a:pPr marL="342900" lvl="0" indent="-342900">
+              <a:buSzPts val="1000"/>
+              <a:buFont typeface="Symbol" pitchFamily="2" charset="2"/>
+              <a:buChar char=""/>
+              <a:tabLst>
+                <a:tab pos="457200" algn="l"/>
+              </a:tabLst>
+            </a:pPr>
+            <a:r>
+              <a:rPr lang="ru-RU" sz="800" b="1" kern="100" dirty="0">
+                <a:effectLst/>
+                <a:latin typeface="Calibri" panose="020F0502020204030204" pitchFamily="34" charset="0"/>
+                <a:ea typeface="Calibri" panose="020F0502020204030204" pitchFamily="34" charset="0"/>
+                <a:cs typeface="Times New Roman" panose="02020603050405020304" pitchFamily="18" charset="0"/>
+              </a:rPr>
+              <a:t>Конкретные объекты</a:t>
+            </a:r>
+            <a:r>
+              <a:rPr lang="ru-RU" sz="800" kern="100" dirty="0">
+                <a:effectLst/>
+                <a:latin typeface="Calibri" panose="020F0502020204030204" pitchFamily="34" charset="0"/>
+                <a:ea typeface="Calibri" panose="020F0502020204030204" pitchFamily="34" charset="0"/>
+                <a:cs typeface="Times New Roman" panose="02020603050405020304" pitchFamily="18" charset="0"/>
+              </a:rPr>
+              <a:t>: "Ньютон", "Солнце", "Автомобиль".</a:t>
+            </a:r>
+          </a:p>
+          <a:p>
+            <a:pPr marL="342900" lvl="0" indent="-342900">
+              <a:buSzPts val="1000"/>
+              <a:buFont typeface="Symbol" pitchFamily="2" charset="2"/>
+              <a:buChar char=""/>
+              <a:tabLst>
+                <a:tab pos="457200" algn="l"/>
+              </a:tabLst>
+            </a:pPr>
+            <a:r>
+              <a:rPr lang="ru-RU" sz="800" b="1" kern="100" dirty="0">
+                <a:effectLst/>
+                <a:latin typeface="Calibri" panose="020F0502020204030204" pitchFamily="34" charset="0"/>
+                <a:ea typeface="Calibri" panose="020F0502020204030204" pitchFamily="34" charset="0"/>
+                <a:cs typeface="Times New Roman" panose="02020603050405020304" pitchFamily="18" charset="0"/>
+              </a:rPr>
+              <a:t>Абстрактные понятия</a:t>
+            </a:r>
+            <a:r>
+              <a:rPr lang="ru-RU" sz="800" kern="100" dirty="0">
+                <a:effectLst/>
+                <a:latin typeface="Calibri" panose="020F0502020204030204" pitchFamily="34" charset="0"/>
+                <a:ea typeface="Calibri" panose="020F0502020204030204" pitchFamily="34" charset="0"/>
+                <a:cs typeface="Times New Roman" panose="02020603050405020304" pitchFamily="18" charset="0"/>
+              </a:rPr>
+              <a:t>: "Наука", "Творчество", "Свобода".</a:t>
+            </a:r>
+          </a:p>
+          <a:p>
+            <a:pPr marL="342900" lvl="0" indent="-342900">
+              <a:buSzPts val="1000"/>
+              <a:buFont typeface="Symbol" pitchFamily="2" charset="2"/>
+              <a:buChar char=""/>
+              <a:tabLst>
+                <a:tab pos="457200" algn="l"/>
+              </a:tabLst>
+            </a:pPr>
+            <a:r>
+              <a:rPr lang="ru-RU" sz="800" b="1" kern="100" dirty="0">
+                <a:effectLst/>
+                <a:latin typeface="Calibri" panose="020F0502020204030204" pitchFamily="34" charset="0"/>
+                <a:ea typeface="Calibri" panose="020F0502020204030204" pitchFamily="34" charset="0"/>
+                <a:cs typeface="Times New Roman" panose="02020603050405020304" pitchFamily="18" charset="0"/>
+              </a:rPr>
+              <a:t>События или действия</a:t>
+            </a:r>
+            <a:r>
+              <a:rPr lang="ru-RU" sz="800" kern="100" dirty="0">
+                <a:effectLst/>
+                <a:latin typeface="Calibri" panose="020F0502020204030204" pitchFamily="34" charset="0"/>
+                <a:ea typeface="Calibri" panose="020F0502020204030204" pitchFamily="34" charset="0"/>
+                <a:cs typeface="Times New Roman" panose="02020603050405020304" pitchFamily="18" charset="0"/>
+              </a:rPr>
+              <a:t>: "Восстание", "Событие", "Изобретение".</a:t>
+            </a:r>
+          </a:p>
+          <a:p>
+            <a:pPr>
+              <a:buNone/>
+            </a:pPr>
+            <a:r>
+              <a:rPr lang="ru-RU" sz="800" kern="100" dirty="0">
+                <a:effectLst/>
+                <a:latin typeface="Calibri" panose="020F0502020204030204" pitchFamily="34" charset="0"/>
+                <a:ea typeface="Calibri" panose="020F0502020204030204" pitchFamily="34" charset="0"/>
+                <a:cs typeface="Times New Roman" panose="02020603050405020304" pitchFamily="18" charset="0"/>
+              </a:rPr>
+              <a:t>Узлы могут также иметь атрибуты, которые добавляют детали к описанию объекта. Например, узел "Солнце" может иметь атрибуты, такие как "температура", "масса" и "радиус".</a:t>
+            </a:r>
+          </a:p>
+        </p:txBody>
+      </p:sp>
+      <p:sp>
+        <p:nvSpPr>
+          <p:cNvPr id="20" name="TextBox 19">
+            <a:extLst>
+              <a:ext uri="{FF2B5EF4-FFF2-40B4-BE49-F238E27FC236}">
+                <a16:creationId xmlns:a16="http://schemas.microsoft.com/office/drawing/2014/main" id="{9D7693E2-D0ED-1A53-2441-08F3350921B6}"/>
+              </a:ext>
+            </a:extLst>
+          </p:cNvPr>
+          <p:cNvSpPr txBox="1"/>
+          <p:nvPr/>
+        </p:nvSpPr>
+        <p:spPr>
+          <a:xfrm>
+            <a:off x="3262792" y="3940873"/>
+            <a:ext cx="3100098" cy="954107"/>
+          </a:xfrm>
+          <a:prstGeom prst="rect">
+            <a:avLst/>
+          </a:prstGeom>
+          <a:noFill/>
+        </p:spPr>
+        <p:txBody>
+          <a:bodyPr wrap="square">
+            <a:spAutoFit/>
+          </a:bodyPr>
+          <a:lstStyle/>
+          <a:p>
+            <a:pPr marL="342900" lvl="0" indent="-342900">
+              <a:buSzPts val="1000"/>
+              <a:buFont typeface="Symbol" pitchFamily="2" charset="2"/>
+              <a:buChar char=""/>
+              <a:tabLst>
+                <a:tab pos="457200" algn="l"/>
+              </a:tabLst>
+            </a:pPr>
+            <a:r>
+              <a:rPr lang="ru-RU" sz="800" b="1" kern="100" dirty="0">
+                <a:effectLst/>
+                <a:latin typeface="Calibri" panose="020F0502020204030204" pitchFamily="34" charset="0"/>
+                <a:ea typeface="Calibri" panose="020F0502020204030204" pitchFamily="34" charset="0"/>
+                <a:cs typeface="Times New Roman" panose="02020603050405020304" pitchFamily="18" charset="0"/>
+              </a:rPr>
+              <a:t>Иерархические отношения</a:t>
+            </a:r>
+            <a:r>
+              <a:rPr lang="ru-RU" sz="800" kern="100" dirty="0">
+                <a:effectLst/>
+                <a:latin typeface="Calibri" panose="020F0502020204030204" pitchFamily="34" charset="0"/>
+                <a:ea typeface="Calibri" panose="020F0502020204030204" pitchFamily="34" charset="0"/>
+                <a:cs typeface="Times New Roman" panose="02020603050405020304" pitchFamily="18" charset="0"/>
+              </a:rPr>
+              <a:t>: "является частью", "подвид" (например, "Собака — подвид — Млекопитающие").</a:t>
+            </a:r>
+          </a:p>
+          <a:p>
+            <a:pPr marL="342900" lvl="0" indent="-342900">
+              <a:buSzPts val="1000"/>
+              <a:buFont typeface="Symbol" pitchFamily="2" charset="2"/>
+              <a:buChar char=""/>
+              <a:tabLst>
+                <a:tab pos="457200" algn="l"/>
+              </a:tabLst>
+            </a:pPr>
+            <a:r>
+              <a:rPr lang="ru-RU" sz="800" b="1" kern="100" dirty="0">
+                <a:effectLst/>
+                <a:latin typeface="Calibri" panose="020F0502020204030204" pitchFamily="34" charset="0"/>
+                <a:ea typeface="Calibri" panose="020F0502020204030204" pitchFamily="34" charset="0"/>
+                <a:cs typeface="Times New Roman" panose="02020603050405020304" pitchFamily="18" charset="0"/>
+              </a:rPr>
+              <a:t>Ассоциативные отношения</a:t>
+            </a:r>
+            <a:r>
+              <a:rPr lang="ru-RU" sz="800" kern="100" dirty="0">
+                <a:effectLst/>
+                <a:latin typeface="Calibri" panose="020F0502020204030204" pitchFamily="34" charset="0"/>
+                <a:ea typeface="Calibri" panose="020F0502020204030204" pitchFamily="34" charset="0"/>
+                <a:cs typeface="Times New Roman" panose="02020603050405020304" pitchFamily="18" charset="0"/>
+              </a:rPr>
+              <a:t>: "связан с", "ассоциируется с" (например, "Молния — связан с — Гроза").</a:t>
+            </a:r>
+            <a:endParaRPr lang="en-US" sz="800" kern="100" dirty="0">
+              <a:effectLst/>
+              <a:latin typeface="Calibri" panose="020F0502020204030204" pitchFamily="34" charset="0"/>
+              <a:ea typeface="Calibri" panose="020F0502020204030204" pitchFamily="34" charset="0"/>
+              <a:cs typeface="Times New Roman" panose="02020603050405020304" pitchFamily="18" charset="0"/>
+            </a:endParaRPr>
+          </a:p>
+          <a:p>
+            <a:pPr marL="342900" lvl="0" indent="-342900">
+              <a:buSzPts val="1000"/>
+              <a:buFont typeface="Symbol" pitchFamily="2" charset="2"/>
+              <a:buChar char=""/>
+              <a:tabLst>
+                <a:tab pos="457200" algn="l"/>
+              </a:tabLst>
+            </a:pPr>
+            <a:r>
+              <a:rPr lang="ru-RU" sz="800" b="1" dirty="0">
+                <a:effectLst/>
+                <a:latin typeface="Calibri" panose="020F0502020204030204" pitchFamily="34" charset="0"/>
+                <a:ea typeface="Calibri" panose="020F0502020204030204" pitchFamily="34" charset="0"/>
+                <a:cs typeface="Times New Roman" panose="02020603050405020304" pitchFamily="18" charset="0"/>
+              </a:rPr>
+              <a:t>Причинно-следственные отношения</a:t>
+            </a:r>
+            <a:r>
+              <a:rPr lang="ru-RU" sz="800" dirty="0">
+                <a:effectLst/>
+                <a:latin typeface="Calibri" panose="020F0502020204030204" pitchFamily="34" charset="0"/>
+                <a:ea typeface="Calibri" panose="020F0502020204030204" pitchFamily="34" charset="0"/>
+                <a:cs typeface="Times New Roman" panose="02020603050405020304" pitchFamily="18" charset="0"/>
+              </a:rPr>
+              <a:t>: "приводит к", "вызывает" (например, "Вулканическое извержение — приводит к — Изменение климата").</a:t>
+            </a:r>
+            <a:r>
+              <a:rPr lang="ru-RU" sz="800" dirty="0">
+                <a:effectLst/>
+              </a:rPr>
+              <a:t> </a:t>
+            </a:r>
+            <a:endParaRPr lang="ru-RU" sz="800" dirty="0"/>
+          </a:p>
+        </p:txBody>
       </p:sp>
     </p:spTree>
   </p:cSld>

</xml_diff>